<commit_message>
Apply workshops: Development D2 (W01–W06); Development word targets 60–80
Co-Authored-By: Claude Opus 5.5 <noreply@anthropic.com>
Claude-Session: https://claude.ai/code/session_01QWUKnGV7MRCnE8883pixoX
</commit_message>
<xml_diff>
--- a/Development_D1/Workshop/D1-W01_Apply_Workshop_L01-L02_Morning_Plans_with_a_Visiting_Pen_Friend.pptx
+++ b/Development_D1/Workshop/D1-W01_Apply_Workshop_L01-L02_Morning_Plans_with_a_Visiting_Pen_Friend.pptx
@@ -19538,7 +19538,7 @@
                 <a:latin typeface="Calibri" pitchFamily="34" charset="0"/>
                 <a:cs typeface="Amiri" pitchFamily="2" charset="-78"/>
               </a:rPr>
-              <a:t>STEP 9 · WRITE YOUR TEXT · ABOUT 70–90 WORDS</a:t>
+              <a:t>STEP 9 · WRITE YOUR TEXT · ABOUT 60–80 WORDS</a:t>
             </a:r>
             <a:endParaRPr lang="en-US" sz="1000" dirty="0"/>
           </a:p>
@@ -19790,7 +19790,7 @@
                 <a:latin typeface="Calibri" pitchFamily="34" charset="0"/>
                 <a:cs typeface="Amiri" pitchFamily="2" charset="-78"/>
               </a:rPr>
-              <a:t>Write a message (about 70–90 words) for your pen-friend, explaining the plan for a school morning during the visit. Include: • when you wake up and what you do first • breakfast: when, what and how long it lasts • when and how you leave for school, with a reason • when the first lesson starts and ends • at least five exact times (with fractions) • your opinion of mornings and one tip for the guest.</a:t>
+              <a:t>Write a message (about 60–80 words) for your pen-friend, explaining the plan for a school morning during the visit. Include: • when you wake up and what you do first • breakfast: when, what and how long it lasts • when and how you leave for school, with a reason • when the first lesson starts and ends • at least five exact times (with fractions) • your opinion of mornings and one tip for the guest.</a:t>
             </a:r>
             <a:endParaRPr lang="en-US" sz="1000" dirty="0"/>
           </a:p>

</xml_diff>